<commit_message>
L01: republish with the PollEv slide
Only change since last night's ship is the marker slide between KISS and
Bad/Good. The poll question and its answer live in the script and in Poll
Everywhere, neither of which ships here, so the public deck shows only
that a poll happens.

Claude-Session: https://claude.ai/code/session_01Nac3M9CHSMSmoRnkHhPjB1
</commit_message>
<xml_diff>
--- a/lectures/L01/slides.pptx
+++ b/lectures/L01/slides.pptx
@@ -61,9 +61,10 @@
     <p:sldId id="309" r:id="rId55"/>
     <p:sldId id="310" r:id="rId56"/>
     <p:sldId id="311" r:id="rId57"/>
+    <p:sldId id="312" r:id="rId58"/>
   </p:sldIdLst>
   <p:notesMasterIdLst>
-    <p:notesMasterId r:id="rId58"/>
+    <p:notesMasterId r:id="rId59"/>
   </p:notesMasterIdLst>
   <p:sldSz cx="9334500" cy="5248275"/>
   <p:notesSz cx="5248275" cy="9334500"/>
@@ -2868,8 +2869,9 @@
           <a:p>
             <a:r>
               <a:rPr lang="en-US" dirty="0"/>
-              <a:t>B almost always produces better results. The model infers the rest.
-Adding caveats compounds ambiguity; it doesn't resolve it.</a:t>
+              <a:t>Presenter cue only — switch to the browser tab holding the activity.
+Set it live, read the question and all four options aloud, give it ~60s,
+show results, then come back to the deck.</a:t>
             </a:r>
             <a:endParaRPr lang="en-US" dirty="0"/>
           </a:p>
@@ -2957,7 +2959,8 @@
           <a:p>
             <a:r>
               <a:rPr lang="en-US" dirty="0"/>
-              <a:t/>
+              <a:t>B almost always produces better results. The model infers the rest.
+Adding caveats compounds ambiguity; it doesn't resolve it.</a:t>
             </a:r>
             <a:endParaRPr lang="en-US" dirty="0"/>
           </a:p>
@@ -3045,7 +3048,7 @@
           <a:p>
             <a:r>
               <a:rPr lang="en-US" dirty="0"/>
-              <a:t>Bridge: We've named the principle. Two questions to pressure-test it.</a:t>
+              <a:t/>
             </a:r>
             <a:endParaRPr lang="en-US" dirty="0"/>
           </a:p>
@@ -3088,6 +3091,94 @@
 </file>
 
 <file path=ppt/notesSlides/notesSlide36.xml><?xml version="1.0" encoding="utf-8"?>
+<p:notes xmlns:a="http://schemas.openxmlformats.org/drawingml/2006/main" xmlns:r="http://schemas.openxmlformats.org/officeDocument/2006/relationships" xmlns:p="http://schemas.openxmlformats.org/presentationml/2006/main">
+  <p:cSld>
+    <p:spTree>
+      <p:nvGrpSpPr>
+        <p:cNvPr id="1" name=""/>
+        <p:cNvGrpSpPr/>
+        <p:nvPr/>
+      </p:nvGrpSpPr>
+      <p:grpSpPr>
+        <a:xfrm>
+          <a:off x="0" y="0"/>
+          <a:ext cx="0" cy="0"/>
+          <a:chOff x="0" y="0"/>
+          <a:chExt cx="0" cy="0"/>
+        </a:xfrm>
+      </p:grpSpPr>
+      <p:sp>
+        <p:nvSpPr>
+          <p:cNvPr id="2" name="Slide Image Placeholder 1"/>
+          <p:cNvSpPr>
+            <a:spLocks noGrp="1" noRot="1" noChangeAspect="1"/>
+          </p:cNvSpPr>
+          <p:nvPr>
+            <p:ph type="sldImg"/>
+          </p:nvPr>
+        </p:nvSpPr>
+        <p:spPr/>
+      </p:sp>
+      <p:sp>
+        <p:nvSpPr>
+          <p:cNvPr id="3" name="Notes Placeholder 2"/>
+          <p:cNvSpPr>
+            <a:spLocks noGrp="1"/>
+          </p:cNvSpPr>
+          <p:nvPr>
+            <p:ph type="body" idx="1"/>
+          </p:nvPr>
+        </p:nvSpPr>
+        <p:spPr/>
+        <p:txBody>
+          <a:bodyPr/>
+          <a:lstStyle/>
+          <a:p>
+            <a:r>
+              <a:rPr lang="en-US" dirty="0"/>
+              <a:t>Bridge: We've named the principle. Two questions to pressure-test it.</a:t>
+            </a:r>
+            <a:endParaRPr lang="en-US" dirty="0"/>
+          </a:p>
+        </p:txBody>
+      </p:sp>
+      <p:sp>
+        <p:nvSpPr>
+          <p:cNvPr id="4" name="Slide Number Placeholder 3"/>
+          <p:cNvSpPr>
+            <a:spLocks noGrp="1"/>
+          </p:cNvSpPr>
+          <p:nvPr>
+            <p:ph type="sldNum" sz="quarter" idx="10"/>
+          </p:nvPr>
+        </p:nvSpPr>
+        <p:spPr/>
+        <p:txBody>
+          <a:bodyPr/>
+          <a:lstStyle/>
+          <a:p>
+            <a:fld id="{F7021451-1387-4CA6-816F-3879F97B5CBC}" type="slidenum">
+              <a:rPr lang="en-US"/>
+              <a:t>36</a:t>
+            </a:fld>
+            <a:endParaRPr lang="en-US"/>
+          </a:p>
+        </p:txBody>
+      </p:sp>
+    </p:spTree>
+    <p:extLst>
+      <p:ext uri="{BB962C8B-B14F-4D97-AF65-F5344CB8AC3E}">
+        <p14:creationId xmlns:p14="http://schemas.microsoft.com/office/powerpoint/2010/main" val="1024086991"/>
+      </p:ext>
+    </p:extLst>
+  </p:cSld>
+  <p:clrMapOvr>
+    <a:masterClrMapping/>
+  </p:clrMapOvr>
+</p:notes>
+</file>
+
+<file path=ppt/notesSlides/notesSlide37.xml><?xml version="1.0" encoding="utf-8"?>
 <p:notes xmlns:a="http://schemas.openxmlformats.org/drawingml/2006/main" xmlns:r="http://schemas.openxmlformats.org/officeDocument/2006/relationships" xmlns:p="http://schemas.openxmlformats.org/presentationml/2006/main">
   <p:cSld>
     <p:spTree>
@@ -3157,7 +3248,7 @@
           <a:p>
             <a:fld id="{F7021451-1387-4CA6-816F-3879F97B5CBC}" type="slidenum">
               <a:rPr lang="en-US"/>
-              <a:t>36</a:t>
+              <a:t>37</a:t>
             </a:fld>
             <a:endParaRPr lang="en-US"/>
           </a:p>
@@ -3176,7 +3267,7 @@
 </p:notes>
 </file>
 
-<file path=ppt/notesSlides/notesSlide37.xml><?xml version="1.0" encoding="utf-8"?>
+<file path=ppt/notesSlides/notesSlide38.xml><?xml version="1.0" encoding="utf-8"?>
 <p:notes xmlns:a="http://schemas.openxmlformats.org/drawingml/2006/main" xmlns:r="http://schemas.openxmlformats.org/officeDocument/2006/relationships" xmlns:p="http://schemas.openxmlformats.org/presentationml/2006/main">
   <p:cSld>
     <p:spTree>
@@ -3246,7 +3337,7 @@
           <a:p>
             <a:fld id="{F7021451-1387-4CA6-816F-3879F97B5CBC}" type="slidenum">
               <a:rPr lang="en-US"/>
-              <a:t>37</a:t>
+              <a:t>38</a:t>
             </a:fld>
             <a:endParaRPr lang="en-US"/>
           </a:p>
@@ -3265,7 +3356,7 @@
 </p:notes>
 </file>
 
-<file path=ppt/notesSlides/notesSlide38.xml><?xml version="1.0" encoding="utf-8"?>
+<file path=ppt/notesSlides/notesSlide39.xml><?xml version="1.0" encoding="utf-8"?>
 <p:notes xmlns:a="http://schemas.openxmlformats.org/drawingml/2006/main" xmlns:r="http://schemas.openxmlformats.org/officeDocument/2006/relationships" xmlns:p="http://schemas.openxmlformats.org/presentationml/2006/main">
   <p:cSld>
     <p:spTree>
@@ -3335,7 +3426,7 @@
           <a:p>
             <a:fld id="{F7021451-1387-4CA6-816F-3879F97B5CBC}" type="slidenum">
               <a:rPr lang="en-US"/>
-              <a:t>38</a:t>
+              <a:t>39</a:t>
             </a:fld>
             <a:endParaRPr lang="en-US"/>
           </a:p>
@@ -3354,7 +3445,95 @@
 </p:notes>
 </file>
 
-<file path=ppt/notesSlides/notesSlide39.xml><?xml version="1.0" encoding="utf-8"?>
+<file path=ppt/notesSlides/notesSlide4.xml><?xml version="1.0" encoding="utf-8"?>
+<p:notes xmlns:a="http://schemas.openxmlformats.org/drawingml/2006/main" xmlns:r="http://schemas.openxmlformats.org/officeDocument/2006/relationships" xmlns:p="http://schemas.openxmlformats.org/presentationml/2006/main">
+  <p:cSld>
+    <p:spTree>
+      <p:nvGrpSpPr>
+        <p:cNvPr id="1" name=""/>
+        <p:cNvGrpSpPr/>
+        <p:nvPr/>
+      </p:nvGrpSpPr>
+      <p:grpSpPr>
+        <a:xfrm>
+          <a:off x="0" y="0"/>
+          <a:ext cx="0" cy="0"/>
+          <a:chOff x="0" y="0"/>
+          <a:chExt cx="0" cy="0"/>
+        </a:xfrm>
+      </p:grpSpPr>
+      <p:sp>
+        <p:nvSpPr>
+          <p:cNvPr id="2" name="Slide Image Placeholder 1"/>
+          <p:cNvSpPr>
+            <a:spLocks noGrp="1" noRot="1" noChangeAspect="1"/>
+          </p:cNvSpPr>
+          <p:nvPr>
+            <p:ph type="sldImg"/>
+          </p:nvPr>
+        </p:nvSpPr>
+        <p:spPr/>
+      </p:sp>
+      <p:sp>
+        <p:nvSpPr>
+          <p:cNvPr id="3" name="Notes Placeholder 2"/>
+          <p:cNvSpPr>
+            <a:spLocks noGrp="1"/>
+          </p:cNvSpPr>
+          <p:nvPr>
+            <p:ph type="body" idx="1"/>
+          </p:nvPr>
+        </p:nvSpPr>
+        <p:spPr/>
+        <p:txBody>
+          <a:bodyPr/>
+          <a:lstStyle/>
+          <a:p>
+            <a:r>
+              <a:rPr lang="en-US" dirty="0"/>
+              <a:t>Land the arc. Note: tool comes LAST. We earn the tool by talking principles first.</a:t>
+            </a:r>
+            <a:endParaRPr lang="en-US" dirty="0"/>
+          </a:p>
+        </p:txBody>
+      </p:sp>
+      <p:sp>
+        <p:nvSpPr>
+          <p:cNvPr id="4" name="Slide Number Placeholder 3"/>
+          <p:cNvSpPr>
+            <a:spLocks noGrp="1"/>
+          </p:cNvSpPr>
+          <p:nvPr>
+            <p:ph type="sldNum" sz="quarter" idx="10"/>
+          </p:nvPr>
+        </p:nvSpPr>
+        <p:spPr/>
+        <p:txBody>
+          <a:bodyPr/>
+          <a:lstStyle/>
+          <a:p>
+            <a:fld id="{F7021451-1387-4CA6-816F-3879F97B5CBC}" type="slidenum">
+              <a:rPr lang="en-US"/>
+              <a:t>4</a:t>
+            </a:fld>
+            <a:endParaRPr lang="en-US"/>
+          </a:p>
+        </p:txBody>
+      </p:sp>
+    </p:spTree>
+    <p:extLst>
+      <p:ext uri="{BB962C8B-B14F-4D97-AF65-F5344CB8AC3E}">
+        <p14:creationId xmlns:p14="http://schemas.microsoft.com/office/powerpoint/2010/main" val="1024086991"/>
+      </p:ext>
+    </p:extLst>
+  </p:cSld>
+  <p:clrMapOvr>
+    <a:masterClrMapping/>
+  </p:clrMapOvr>
+</p:notes>
+</file>
+
+<file path=ppt/notesSlides/notesSlide40.xml><?xml version="1.0" encoding="utf-8"?>
 <p:notes xmlns:a="http://schemas.openxmlformats.org/drawingml/2006/main" xmlns:r="http://schemas.openxmlformats.org/officeDocument/2006/relationships" xmlns:p="http://schemas.openxmlformats.org/presentationml/2006/main">
   <p:cSld>
     <p:spTree>
@@ -3423,7 +3602,7 @@
           <a:p>
             <a:fld id="{F7021451-1387-4CA6-816F-3879F97B5CBC}" type="slidenum">
               <a:rPr lang="en-US"/>
-              <a:t>39</a:t>
+              <a:t>40</a:t>
             </a:fld>
             <a:endParaRPr lang="en-US"/>
           </a:p>
@@ -3442,95 +3621,7 @@
 </p:notes>
 </file>
 
-<file path=ppt/notesSlides/notesSlide4.xml><?xml version="1.0" encoding="utf-8"?>
-<p:notes xmlns:a="http://schemas.openxmlformats.org/drawingml/2006/main" xmlns:r="http://schemas.openxmlformats.org/officeDocument/2006/relationships" xmlns:p="http://schemas.openxmlformats.org/presentationml/2006/main">
-  <p:cSld>
-    <p:spTree>
-      <p:nvGrpSpPr>
-        <p:cNvPr id="1" name=""/>
-        <p:cNvGrpSpPr/>
-        <p:nvPr/>
-      </p:nvGrpSpPr>
-      <p:grpSpPr>
-        <a:xfrm>
-          <a:off x="0" y="0"/>
-          <a:ext cx="0" cy="0"/>
-          <a:chOff x="0" y="0"/>
-          <a:chExt cx="0" cy="0"/>
-        </a:xfrm>
-      </p:grpSpPr>
-      <p:sp>
-        <p:nvSpPr>
-          <p:cNvPr id="2" name="Slide Image Placeholder 1"/>
-          <p:cNvSpPr>
-            <a:spLocks noGrp="1" noRot="1" noChangeAspect="1"/>
-          </p:cNvSpPr>
-          <p:nvPr>
-            <p:ph type="sldImg"/>
-          </p:nvPr>
-        </p:nvSpPr>
-        <p:spPr/>
-      </p:sp>
-      <p:sp>
-        <p:nvSpPr>
-          <p:cNvPr id="3" name="Notes Placeholder 2"/>
-          <p:cNvSpPr>
-            <a:spLocks noGrp="1"/>
-          </p:cNvSpPr>
-          <p:nvPr>
-            <p:ph type="body" idx="1"/>
-          </p:nvPr>
-        </p:nvSpPr>
-        <p:spPr/>
-        <p:txBody>
-          <a:bodyPr/>
-          <a:lstStyle/>
-          <a:p>
-            <a:r>
-              <a:rPr lang="en-US" dirty="0"/>
-              <a:t>Land the arc. Note: tool comes LAST. We earn the tool by talking principles first.</a:t>
-            </a:r>
-            <a:endParaRPr lang="en-US" dirty="0"/>
-          </a:p>
-        </p:txBody>
-      </p:sp>
-      <p:sp>
-        <p:nvSpPr>
-          <p:cNvPr id="4" name="Slide Number Placeholder 3"/>
-          <p:cNvSpPr>
-            <a:spLocks noGrp="1"/>
-          </p:cNvSpPr>
-          <p:nvPr>
-            <p:ph type="sldNum" sz="quarter" idx="10"/>
-          </p:nvPr>
-        </p:nvSpPr>
-        <p:spPr/>
-        <p:txBody>
-          <a:bodyPr/>
-          <a:lstStyle/>
-          <a:p>
-            <a:fld id="{F7021451-1387-4CA6-816F-3879F97B5CBC}" type="slidenum">
-              <a:rPr lang="en-US"/>
-              <a:t>4</a:t>
-            </a:fld>
-            <a:endParaRPr lang="en-US"/>
-          </a:p>
-        </p:txBody>
-      </p:sp>
-    </p:spTree>
-    <p:extLst>
-      <p:ext uri="{BB962C8B-B14F-4D97-AF65-F5344CB8AC3E}">
-        <p14:creationId xmlns:p14="http://schemas.microsoft.com/office/powerpoint/2010/main" val="1024086991"/>
-      </p:ext>
-    </p:extLst>
-  </p:cSld>
-  <p:clrMapOvr>
-    <a:masterClrMapping/>
-  </p:clrMapOvr>
-</p:notes>
-</file>
-
-<file path=ppt/notesSlides/notesSlide40.xml><?xml version="1.0" encoding="utf-8"?>
+<file path=ppt/notesSlides/notesSlide41.xml><?xml version="1.0" encoding="utf-8"?>
 <p:notes xmlns:a="http://schemas.openxmlformats.org/drawingml/2006/main" xmlns:r="http://schemas.openxmlformats.org/officeDocument/2006/relationships" xmlns:p="http://schemas.openxmlformats.org/presentationml/2006/main">
   <p:cSld>
     <p:spTree>
@@ -3601,7 +3692,7 @@
           <a:p>
             <a:fld id="{F7021451-1387-4CA6-816F-3879F97B5CBC}" type="slidenum">
               <a:rPr lang="en-US"/>
-              <a:t>40</a:t>
+              <a:t>41</a:t>
             </a:fld>
             <a:endParaRPr lang="en-US"/>
           </a:p>
@@ -3620,7 +3711,7 @@
 </p:notes>
 </file>
 
-<file path=ppt/notesSlides/notesSlide41.xml><?xml version="1.0" encoding="utf-8"?>
+<file path=ppt/notesSlides/notesSlide42.xml><?xml version="1.0" encoding="utf-8"?>
 <p:notes xmlns:a="http://schemas.openxmlformats.org/drawingml/2006/main" xmlns:r="http://schemas.openxmlformats.org/officeDocument/2006/relationships" xmlns:p="http://schemas.openxmlformats.org/presentationml/2006/main">
   <p:cSld>
     <p:spTree>
@@ -3691,7 +3782,7 @@
           <a:p>
             <a:fld id="{F7021451-1387-4CA6-816F-3879F97B5CBC}" type="slidenum">
               <a:rPr lang="en-US"/>
-              <a:t>41</a:t>
+              <a:t>42</a:t>
             </a:fld>
             <a:endParaRPr lang="en-US"/>
           </a:p>
@@ -3710,7 +3801,7 @@
 </p:notes>
 </file>
 
-<file path=ppt/notesSlides/notesSlide42.xml><?xml version="1.0" encoding="utf-8"?>
+<file path=ppt/notesSlides/notesSlide43.xml><?xml version="1.0" encoding="utf-8"?>
 <p:notes xmlns:a="http://schemas.openxmlformats.org/drawingml/2006/main" xmlns:r="http://schemas.openxmlformats.org/officeDocument/2006/relationships" xmlns:p="http://schemas.openxmlformats.org/presentationml/2006/main">
   <p:cSld>
     <p:spTree>
@@ -3781,7 +3872,7 @@
           <a:p>
             <a:fld id="{F7021451-1387-4CA6-816F-3879F97B5CBC}" type="slidenum">
               <a:rPr lang="en-US"/>
-              <a:t>42</a:t>
+              <a:t>43</a:t>
             </a:fld>
             <a:endParaRPr lang="en-US"/>
           </a:p>
@@ -3800,7 +3891,7 @@
 </p:notes>
 </file>
 
-<file path=ppt/notesSlides/notesSlide43.xml><?xml version="1.0" encoding="utf-8"?>
+<file path=ppt/notesSlides/notesSlide44.xml><?xml version="1.0" encoding="utf-8"?>
 <p:notes xmlns:a="http://schemas.openxmlformats.org/drawingml/2006/main" xmlns:r="http://schemas.openxmlformats.org/officeDocument/2006/relationships" xmlns:p="http://schemas.openxmlformats.org/presentationml/2006/main">
   <p:cSld>
     <p:spTree>
@@ -3871,7 +3962,7 @@
           <a:p>
             <a:fld id="{F7021451-1387-4CA6-816F-3879F97B5CBC}" type="slidenum">
               <a:rPr lang="en-US"/>
-              <a:t>43</a:t>
+              <a:t>44</a:t>
             </a:fld>
             <a:endParaRPr lang="en-US"/>
           </a:p>
@@ -3890,7 +3981,7 @@
 </p:notes>
 </file>
 
-<file path=ppt/notesSlides/notesSlide44.xml><?xml version="1.0" encoding="utf-8"?>
+<file path=ppt/notesSlides/notesSlide45.xml><?xml version="1.0" encoding="utf-8"?>
 <p:notes xmlns:a="http://schemas.openxmlformats.org/drawingml/2006/main" xmlns:r="http://schemas.openxmlformats.org/officeDocument/2006/relationships" xmlns:p="http://schemas.openxmlformats.org/presentationml/2006/main">
   <p:cSld>
     <p:spTree>
@@ -3960,7 +4051,7 @@
           <a:p>
             <a:fld id="{F7021451-1387-4CA6-816F-3879F97B5CBC}" type="slidenum">
               <a:rPr lang="en-US"/>
-              <a:t>44</a:t>
+              <a:t>45</a:t>
             </a:fld>
             <a:endParaRPr lang="en-US"/>
           </a:p>
@@ -3979,7 +4070,7 @@
 </p:notes>
 </file>
 
-<file path=ppt/notesSlides/notesSlide45.xml><?xml version="1.0" encoding="utf-8"?>
+<file path=ppt/notesSlides/notesSlide46.xml><?xml version="1.0" encoding="utf-8"?>
 <p:notes xmlns:a="http://schemas.openxmlformats.org/drawingml/2006/main" xmlns:r="http://schemas.openxmlformats.org/officeDocument/2006/relationships" xmlns:p="http://schemas.openxmlformats.org/presentationml/2006/main">
   <p:cSld>
     <p:spTree>
@@ -4048,7 +4139,7 @@
           <a:p>
             <a:fld id="{F7021451-1387-4CA6-816F-3879F97B5CBC}" type="slidenum">
               <a:rPr lang="en-US"/>
-              <a:t>45</a:t>
+              <a:t>46</a:t>
             </a:fld>
             <a:endParaRPr lang="en-US"/>
           </a:p>
@@ -4067,7 +4158,7 @@
 </p:notes>
 </file>
 
-<file path=ppt/notesSlides/notesSlide46.xml><?xml version="1.0" encoding="utf-8"?>
+<file path=ppt/notesSlides/notesSlide47.xml><?xml version="1.0" encoding="utf-8"?>
 <p:notes xmlns:a="http://schemas.openxmlformats.org/drawingml/2006/main" xmlns:r="http://schemas.openxmlformats.org/officeDocument/2006/relationships" xmlns:p="http://schemas.openxmlformats.org/presentationml/2006/main">
   <p:cSld>
     <p:spTree>
@@ -4136,7 +4227,7 @@
           <a:p>
             <a:fld id="{F7021451-1387-4CA6-816F-3879F97B5CBC}" type="slidenum">
               <a:rPr lang="en-US"/>
-              <a:t>46</a:t>
+              <a:t>47</a:t>
             </a:fld>
             <a:endParaRPr lang="en-US"/>
           </a:p>
@@ -4155,7 +4246,7 @@
 </p:notes>
 </file>
 
-<file path=ppt/notesSlides/notesSlide47.xml><?xml version="1.0" encoding="utf-8"?>
+<file path=ppt/notesSlides/notesSlide48.xml><?xml version="1.0" encoding="utf-8"?>
 <p:notes xmlns:a="http://schemas.openxmlformats.org/drawingml/2006/main" xmlns:r="http://schemas.openxmlformats.org/officeDocument/2006/relationships" xmlns:p="http://schemas.openxmlformats.org/presentationml/2006/main">
   <p:cSld>
     <p:spTree>
@@ -4224,7 +4315,7 @@
           <a:p>
             <a:fld id="{F7021451-1387-4CA6-816F-3879F97B5CBC}" type="slidenum">
               <a:rPr lang="en-US"/>
-              <a:t>47</a:t>
+              <a:t>48</a:t>
             </a:fld>
             <a:endParaRPr lang="en-US"/>
           </a:p>
@@ -4243,7 +4334,7 @@
 </p:notes>
 </file>
 
-<file path=ppt/notesSlides/notesSlide48.xml><?xml version="1.0" encoding="utf-8"?>
+<file path=ppt/notesSlides/notesSlide49.xml><?xml version="1.0" encoding="utf-8"?>
 <p:notes xmlns:a="http://schemas.openxmlformats.org/drawingml/2006/main" xmlns:r="http://schemas.openxmlformats.org/officeDocument/2006/relationships" xmlns:p="http://schemas.openxmlformats.org/presentationml/2006/main">
   <p:cSld>
     <p:spTree>
@@ -4312,7 +4403,7 @@
           <a:p>
             <a:fld id="{F7021451-1387-4CA6-816F-3879F97B5CBC}" type="slidenum">
               <a:rPr lang="en-US"/>
-              <a:t>48</a:t>
+              <a:t>49</a:t>
             </a:fld>
             <a:endParaRPr lang="en-US"/>
           </a:p>
@@ -4331,7 +4422,95 @@
 </p:notes>
 </file>
 
-<file path=ppt/notesSlides/notesSlide49.xml><?xml version="1.0" encoding="utf-8"?>
+<file path=ppt/notesSlides/notesSlide5.xml><?xml version="1.0" encoding="utf-8"?>
+<p:notes xmlns:a="http://schemas.openxmlformats.org/drawingml/2006/main" xmlns:r="http://schemas.openxmlformats.org/officeDocument/2006/relationships" xmlns:p="http://schemas.openxmlformats.org/presentationml/2006/main">
+  <p:cSld>
+    <p:spTree>
+      <p:nvGrpSpPr>
+        <p:cNvPr id="1" name=""/>
+        <p:cNvGrpSpPr/>
+        <p:nvPr/>
+      </p:nvGrpSpPr>
+      <p:grpSpPr>
+        <a:xfrm>
+          <a:off x="0" y="0"/>
+          <a:ext cx="0" cy="0"/>
+          <a:chOff x="0" y="0"/>
+          <a:chExt cx="0" cy="0"/>
+        </a:xfrm>
+      </p:grpSpPr>
+      <p:sp>
+        <p:nvSpPr>
+          <p:cNvPr id="2" name="Slide Image Placeholder 1"/>
+          <p:cNvSpPr>
+            <a:spLocks noGrp="1" noRot="1" noChangeAspect="1"/>
+          </p:cNvSpPr>
+          <p:nvPr>
+            <p:ph type="sldImg"/>
+          </p:nvPr>
+        </p:nvSpPr>
+        <p:spPr/>
+      </p:sp>
+      <p:sp>
+        <p:nvSpPr>
+          <p:cNvPr id="3" name="Notes Placeholder 2"/>
+          <p:cNvSpPr>
+            <a:spLocks noGrp="1"/>
+          </p:cNvSpPr>
+          <p:nvPr>
+            <p:ph type="body" idx="1"/>
+          </p:nvPr>
+        </p:nvSpPr>
+        <p:spPr/>
+        <p:txBody>
+          <a:bodyPr/>
+          <a:lstStyle/>
+          <a:p>
+            <a:r>
+              <a:rPr lang="en-US" dirty="0"/>
+              <a:t>Land the arc. Note: tool comes LAST. We earn the tool by talking principles first.</a:t>
+            </a:r>
+            <a:endParaRPr lang="en-US" dirty="0"/>
+          </a:p>
+        </p:txBody>
+      </p:sp>
+      <p:sp>
+        <p:nvSpPr>
+          <p:cNvPr id="4" name="Slide Number Placeholder 3"/>
+          <p:cNvSpPr>
+            <a:spLocks noGrp="1"/>
+          </p:cNvSpPr>
+          <p:nvPr>
+            <p:ph type="sldNum" sz="quarter" idx="10"/>
+          </p:nvPr>
+        </p:nvSpPr>
+        <p:spPr/>
+        <p:txBody>
+          <a:bodyPr/>
+          <a:lstStyle/>
+          <a:p>
+            <a:fld id="{F7021451-1387-4CA6-816F-3879F97B5CBC}" type="slidenum">
+              <a:rPr lang="en-US"/>
+              <a:t>5</a:t>
+            </a:fld>
+            <a:endParaRPr lang="en-US"/>
+          </a:p>
+        </p:txBody>
+      </p:sp>
+    </p:spTree>
+    <p:extLst>
+      <p:ext uri="{BB962C8B-B14F-4D97-AF65-F5344CB8AC3E}">
+        <p14:creationId xmlns:p14="http://schemas.microsoft.com/office/powerpoint/2010/main" val="1024086991"/>
+      </p:ext>
+    </p:extLst>
+  </p:cSld>
+  <p:clrMapOvr>
+    <a:masterClrMapping/>
+  </p:clrMapOvr>
+</p:notes>
+</file>
+
+<file path=ppt/notesSlides/notesSlide50.xml><?xml version="1.0" encoding="utf-8"?>
 <p:notes xmlns:a="http://schemas.openxmlformats.org/drawingml/2006/main" xmlns:r="http://schemas.openxmlformats.org/officeDocument/2006/relationships" xmlns:p="http://schemas.openxmlformats.org/presentationml/2006/main">
   <p:cSld>
     <p:spTree>
@@ -4400,7 +4579,7 @@
           <a:p>
             <a:fld id="{F7021451-1387-4CA6-816F-3879F97B5CBC}" type="slidenum">
               <a:rPr lang="en-US"/>
-              <a:t>49</a:t>
+              <a:t>50</a:t>
             </a:fld>
             <a:endParaRPr lang="en-US"/>
           </a:p>
@@ -4419,7 +4598,7 @@
 </p:notes>
 </file>
 
-<file path=ppt/notesSlides/notesSlide5.xml><?xml version="1.0" encoding="utf-8"?>
+<file path=ppt/notesSlides/notesSlide51.xml><?xml version="1.0" encoding="utf-8"?>
 <p:notes xmlns:a="http://schemas.openxmlformats.org/drawingml/2006/main" xmlns:r="http://schemas.openxmlformats.org/officeDocument/2006/relationships" xmlns:p="http://schemas.openxmlformats.org/presentationml/2006/main">
   <p:cSld>
     <p:spTree>
@@ -4465,7 +4644,7 @@
           <a:p>
             <a:r>
               <a:rPr lang="en-US" dirty="0"/>
-              <a:t>Land the arc. Note: tool comes LAST. We earn the tool by talking principles first.</a:t>
+              <a:t/>
             </a:r>
             <a:endParaRPr lang="en-US" dirty="0"/>
           </a:p>
@@ -4488,7 +4667,7 @@
           <a:p>
             <a:fld id="{F7021451-1387-4CA6-816F-3879F97B5CBC}" type="slidenum">
               <a:rPr lang="en-US"/>
-              <a:t>5</a:t>
+              <a:t>51</a:t>
             </a:fld>
             <a:endParaRPr lang="en-US"/>
           </a:p>
@@ -4507,7 +4686,7 @@
 </p:notes>
 </file>
 
-<file path=ppt/notesSlides/notesSlide50.xml><?xml version="1.0" encoding="utf-8"?>
+<file path=ppt/notesSlides/notesSlide52.xml><?xml version="1.0" encoding="utf-8"?>
 <p:notes xmlns:a="http://schemas.openxmlformats.org/drawingml/2006/main" xmlns:r="http://schemas.openxmlformats.org/officeDocument/2006/relationships" xmlns:p="http://schemas.openxmlformats.org/presentationml/2006/main">
   <p:cSld>
     <p:spTree>
@@ -4576,7 +4755,7 @@
           <a:p>
             <a:fld id="{F7021451-1387-4CA6-816F-3879F97B5CBC}" type="slidenum">
               <a:rPr lang="en-US"/>
-              <a:t>50</a:t>
+              <a:t>52</a:t>
             </a:fld>
             <a:endParaRPr lang="en-US"/>
           </a:p>
@@ -4595,7 +4774,7 @@
 </p:notes>
 </file>
 
-<file path=ppt/notesSlides/notesSlide51.xml><?xml version="1.0" encoding="utf-8"?>
+<file path=ppt/notesSlides/notesSlide53.xml><?xml version="1.0" encoding="utf-8"?>
 <p:notes xmlns:a="http://schemas.openxmlformats.org/drawingml/2006/main" xmlns:r="http://schemas.openxmlformats.org/officeDocument/2006/relationships" xmlns:p="http://schemas.openxmlformats.org/presentationml/2006/main">
   <p:cSld>
     <p:spTree>
@@ -4664,7 +4843,7 @@
           <a:p>
             <a:fld id="{F7021451-1387-4CA6-816F-3879F97B5CBC}" type="slidenum">
               <a:rPr lang="en-US"/>
-              <a:t>51</a:t>
+              <a:t>53</a:t>
             </a:fld>
             <a:endParaRPr lang="en-US"/>
           </a:p>
@@ -4683,7 +4862,7 @@
 </p:notes>
 </file>
 
-<file path=ppt/notesSlides/notesSlide52.xml><?xml version="1.0" encoding="utf-8"?>
+<file path=ppt/notesSlides/notesSlide54.xml><?xml version="1.0" encoding="utf-8"?>
 <p:notes xmlns:a="http://schemas.openxmlformats.org/drawingml/2006/main" xmlns:r="http://schemas.openxmlformats.org/officeDocument/2006/relationships" xmlns:p="http://schemas.openxmlformats.org/presentationml/2006/main">
   <p:cSld>
     <p:spTree>
@@ -4752,7 +4931,7 @@
           <a:p>
             <a:fld id="{F7021451-1387-4CA6-816F-3879F97B5CBC}" type="slidenum">
               <a:rPr lang="en-US"/>
-              <a:t>52</a:t>
+              <a:t>54</a:t>
             </a:fld>
             <a:endParaRPr lang="en-US"/>
           </a:p>
@@ -4771,7 +4950,7 @@
 </p:notes>
 </file>
 
-<file path=ppt/notesSlides/notesSlide53.xml><?xml version="1.0" encoding="utf-8"?>
+<file path=ppt/notesSlides/notesSlide55.xml><?xml version="1.0" encoding="utf-8"?>
 <p:notes xmlns:a="http://schemas.openxmlformats.org/drawingml/2006/main" xmlns:r="http://schemas.openxmlformats.org/officeDocument/2006/relationships" xmlns:p="http://schemas.openxmlformats.org/presentationml/2006/main">
   <p:cSld>
     <p:spTree>
@@ -4840,7 +5019,7 @@
           <a:p>
             <a:fld id="{F7021451-1387-4CA6-816F-3879F97B5CBC}" type="slidenum">
               <a:rPr lang="en-US"/>
-              <a:t>53</a:t>
+              <a:t>55</a:t>
             </a:fld>
             <a:endParaRPr lang="en-US"/>
           </a:p>
@@ -4859,95 +5038,7 @@
 </p:notes>
 </file>
 
-<file path=ppt/notesSlides/notesSlide54.xml><?xml version="1.0" encoding="utf-8"?>
-<p:notes xmlns:a="http://schemas.openxmlformats.org/drawingml/2006/main" xmlns:r="http://schemas.openxmlformats.org/officeDocument/2006/relationships" xmlns:p="http://schemas.openxmlformats.org/presentationml/2006/main">
-  <p:cSld>
-    <p:spTree>
-      <p:nvGrpSpPr>
-        <p:cNvPr id="1" name=""/>
-        <p:cNvGrpSpPr/>
-        <p:nvPr/>
-      </p:nvGrpSpPr>
-      <p:grpSpPr>
-        <a:xfrm>
-          <a:off x="0" y="0"/>
-          <a:ext cx="0" cy="0"/>
-          <a:chOff x="0" y="0"/>
-          <a:chExt cx="0" cy="0"/>
-        </a:xfrm>
-      </p:grpSpPr>
-      <p:sp>
-        <p:nvSpPr>
-          <p:cNvPr id="2" name="Slide Image Placeholder 1"/>
-          <p:cNvSpPr>
-            <a:spLocks noGrp="1" noRot="1" noChangeAspect="1"/>
-          </p:cNvSpPr>
-          <p:nvPr>
-            <p:ph type="sldImg"/>
-          </p:nvPr>
-        </p:nvSpPr>
-        <p:spPr/>
-      </p:sp>
-      <p:sp>
-        <p:nvSpPr>
-          <p:cNvPr id="3" name="Notes Placeholder 2"/>
-          <p:cNvSpPr>
-            <a:spLocks noGrp="1"/>
-          </p:cNvSpPr>
-          <p:nvPr>
-            <p:ph type="body" idx="1"/>
-          </p:nvPr>
-        </p:nvSpPr>
-        <p:spPr/>
-        <p:txBody>
-          <a:bodyPr/>
-          <a:lstStyle/>
-          <a:p>
-            <a:r>
-              <a:rPr lang="en-US" dirty="0"/>
-              <a:t/>
-            </a:r>
-            <a:endParaRPr lang="en-US" dirty="0"/>
-          </a:p>
-        </p:txBody>
-      </p:sp>
-      <p:sp>
-        <p:nvSpPr>
-          <p:cNvPr id="4" name="Slide Number Placeholder 3"/>
-          <p:cNvSpPr>
-            <a:spLocks noGrp="1"/>
-          </p:cNvSpPr>
-          <p:nvPr>
-            <p:ph type="sldNum" sz="quarter" idx="10"/>
-          </p:nvPr>
-        </p:nvSpPr>
-        <p:spPr/>
-        <p:txBody>
-          <a:bodyPr/>
-          <a:lstStyle/>
-          <a:p>
-            <a:fld id="{F7021451-1387-4CA6-816F-3879F97B5CBC}" type="slidenum">
-              <a:rPr lang="en-US"/>
-              <a:t>54</a:t>
-            </a:fld>
-            <a:endParaRPr lang="en-US"/>
-          </a:p>
-        </p:txBody>
-      </p:sp>
-    </p:spTree>
-    <p:extLst>
-      <p:ext uri="{BB962C8B-B14F-4D97-AF65-F5344CB8AC3E}">
-        <p14:creationId xmlns:p14="http://schemas.microsoft.com/office/powerpoint/2010/main" val="1024086991"/>
-      </p:ext>
-    </p:extLst>
-  </p:cSld>
-  <p:clrMapOvr>
-    <a:masterClrMapping/>
-  </p:clrMapOvr>
-</p:notes>
-</file>
-
-<file path=ppt/notesSlides/notesSlide55.xml><?xml version="1.0" encoding="utf-8"?>
+<file path=ppt/notesSlides/notesSlide56.xml><?xml version="1.0" encoding="utf-8"?>
 <p:notes xmlns:a="http://schemas.openxmlformats.org/drawingml/2006/main" xmlns:r="http://schemas.openxmlformats.org/officeDocument/2006/relationships" xmlns:p="http://schemas.openxmlformats.org/presentationml/2006/main">
   <p:cSld>
     <p:spTree>
@@ -5017,7 +5108,7 @@
           <a:p>
             <a:fld id="{F7021451-1387-4CA6-816F-3879F97B5CBC}" type="slidenum">
               <a:rPr lang="en-US"/>
-              <a:t>55</a:t>
+              <a:t>56</a:t>
             </a:fld>
             <a:endParaRPr lang="en-US"/>
           </a:p>
@@ -5036,7 +5127,7 @@
 </p:notes>
 </file>
 
-<file path=ppt/notesSlides/notesSlide56.xml><?xml version="1.0" encoding="utf-8"?>
+<file path=ppt/notesSlides/notesSlide57.xml><?xml version="1.0" encoding="utf-8"?>
 <p:notes xmlns:a="http://schemas.openxmlformats.org/drawingml/2006/main" xmlns:r="http://schemas.openxmlformats.org/officeDocument/2006/relationships" xmlns:p="http://schemas.openxmlformats.org/presentationml/2006/main">
   <p:cSld>
     <p:spTree>
@@ -5105,7 +5196,7 @@
           <a:p>
             <a:fld id="{F7021451-1387-4CA6-816F-3879F97B5CBC}" type="slidenum">
               <a:rPr lang="en-US"/>
-              <a:t>56</a:t>
+              <a:t>57</a:t>
             </a:fld>
             <a:endParaRPr lang="en-US"/>
           </a:p>
@@ -7775,6 +7866,45 @@
 <file path=ppt/slides/slide56.xml><?xml version="1.0" encoding="utf-8"?>
 <p:sld xmlns:a="http://schemas.openxmlformats.org/drawingml/2006/main" xmlns:r="http://schemas.openxmlformats.org/officeDocument/2006/relationships" xmlns:p="http://schemas.openxmlformats.org/presentationml/2006/main">
   <p:cSld name="Slide 56">
+    <p:bg>
+      <p:bgPr>
+        <a:blipFill dpi="0" rotWithShape="1">
+          <a:blip r:embed="rId1">
+            <a:lum/>
+          </a:blip>
+          <a:srcRect/>
+          <a:stretch>
+            <a:fillRect/>
+          </a:stretch>
+        </a:blipFill>
+        <a:effectLst/>
+      </p:bgPr>
+    </p:bg>
+    <p:spTree>
+      <p:nvGrpSpPr>
+        <p:cNvPr id="1" name=""/>
+        <p:cNvGrpSpPr/>
+        <p:nvPr/>
+      </p:nvGrpSpPr>
+      <p:grpSpPr>
+        <a:xfrm>
+          <a:off x="0" y="0"/>
+          <a:ext cx="0" cy="0"/>
+          <a:chOff x="0" y="0"/>
+          <a:chExt cx="0" cy="0"/>
+        </a:xfrm>
+      </p:grpSpPr>
+    </p:spTree>
+  </p:cSld>
+  <p:clrMapOvr>
+    <a:masterClrMapping/>
+  </p:clrMapOvr>
+</p:sld>
+</file>
+
+<file path=ppt/slides/slide57.xml><?xml version="1.0" encoding="utf-8"?>
+<p:sld xmlns:a="http://schemas.openxmlformats.org/drawingml/2006/main" xmlns:r="http://schemas.openxmlformats.org/officeDocument/2006/relationships" xmlns:p="http://schemas.openxmlformats.org/presentationml/2006/main">
+  <p:cSld name="Slide 57">
     <p:bg>
       <p:bgPr>
         <a:blipFill dpi="0" rotWithShape="1">

</xml_diff>